<commit_message>
Remove speaker notes from Grade 5 English Adventure demo deck.
</commit_message>
<xml_diff>
--- a/Grade5_English_Adventure_60min_Demo.pptx
+++ b/Grade5_English_Adventure_60min_Demo.pptx
@@ -536,53 +536,7 @@
         <p:txBody>
           <a:bodyPr/>
           <a:lstStyle/>
-          <a:p>
-            <a:r>
-              <a:t>⏱ TIMING: 0–5 min</a:t>
-            </a:r>
-          </a:p>
           <a:p/>
-          <a:p>
-            <a:r>
-              <a:t>SAY: Hi! I am so happy to meet you. Today we are going on an English adventure. We will read a true-to-life turtle rescue story, play detective games, and you will earn stars along the way. There is no test today — only fun.</a:t>
-            </a:r>
-          </a:p>
-          <a:p/>
-          <a:p>
-            <a:r>
-              <a:t>HOW TO RUN IT: Smile, wave, say your name. Ask the student to say their name and one thing they like. Keep this under 60 seconds so the energy stays high.</a:t>
-            </a:r>
-          </a:p>
-          <a:p/>
-          <a:p>
-            <a:r>
-              <a:t>EXPECTED ANSWERS: Student says their name and one interest (soccer, drawing, video games, animals).</a:t>
-            </a:r>
-          </a:p>
-          <a:p/>
-          <a:p>
-            <a:r>
-              <a:t>COMMON MISTAKES: Very short one-word answers; nervous silence at the start.</a:t>
-            </a:r>
-          </a:p>
-          <a:p/>
-          <a:p>
-            <a:r>
-              <a:t>IF THE STUDENT STRUGGLES (easier step): Give a choice instead of an open question: 'Do you like animals or sports more?'</a:t>
-            </a:r>
-          </a:p>
-          <a:p/>
-          <a:p>
-            <a:r>
-              <a:t>IF THE STUDENT FINISHES FAST (bonus): Ask: 'Can you tell me ONE reason you like it?'</a:t>
-            </a:r>
-          </a:p>
-          <a:p/>
-          <a:p>
-            <a:r>
-              <a:t>ENCOURAGE: You're already speaking English — great start! ⭐</a:t>
-            </a:r>
-          </a:p>
         </p:txBody>
       </p:sp>
       <p:sp>
@@ -648,53 +602,7 @@
         <p:txBody>
           <a:bodyPr/>
           <a:lstStyle/>
-          <a:p>
-            <a:r>
-              <a:t>⏱ TIMING: 10–20 min</a:t>
-            </a:r>
-          </a:p>
           <a:p/>
-          <a:p>
-            <a:r>
-              <a:t>SAY: Now we read together, at the same time, like a team. If I go too fast, squeeze the table and I'll slow down.</a:t>
-            </a:r>
-          </a:p>
-          <a:p/>
-          <a:p>
-            <a:r>
-              <a:t>HOW TO RUN IT: Choral read at a comfortable pace. Let your voice drop slightly so the student's voice leads by the second paragraph.</a:t>
-            </a:r>
-          </a:p>
-          <a:p/>
-          <a:p>
-            <a:r>
-              <a:t>EXPECTED ANSWERS: Check question: 'What was the problem?' → Three hatchlings fell into a deep tire track and could not climb out.</a:t>
-            </a:r>
-          </a:p>
-          <a:p/>
-          <a:p>
-            <a:r>
-              <a:t>COMMON MISTAKES: Rushing past punctuation; mumbling on 'scrambled'.</a:t>
-            </a:r>
-          </a:p>
-          <a:p/>
-          <a:p>
-            <a:r>
-              <a:t>IF THE STUDENT STRUGGLES (easier step): Read one sentence, then have them echo it back before moving on.</a:t>
-            </a:r>
-          </a:p>
-          <a:p/>
-          <a:p>
-            <a:r>
-              <a:t>IF THE STUDENT FINISHES FAST (bonus): Ask: 'Why was Maya NOT allowed to pick up the turtles?'</a:t>
-            </a:r>
-          </a:p>
-          <a:p/>
-          <a:p>
-            <a:r>
-              <a:t>ENCOURAGE: Our voices matched perfectly — that's real fluency! ⭐</a:t>
-            </a:r>
-          </a:p>
         </p:txBody>
       </p:sp>
       <p:sp>
@@ -760,53 +668,7 @@
         <p:txBody>
           <a:bodyPr/>
           <a:lstStyle/>
-          <a:p>
-            <a:r>
-              <a:t>⏱ TIMING: 10–20 min</a:t>
-            </a:r>
-          </a:p>
           <a:p/>
-          <a:p>
-            <a:r>
-              <a:t>SAY: This is your part. You read it on your own, out loud. Take your time — if a word looks hard, pause and I will help. There is no rush at all.</a:t>
-            </a:r>
-          </a:p>
-          <a:p/>
-          <a:p>
-            <a:r>
-              <a:t>HOW TO RUN IT: Stay quiet unless they stall for more than 3 seconds. Do not correct small errors mid-sentence; note them and praise first at the end.</a:t>
-            </a:r>
-          </a:p>
-          <a:p/>
-          <a:p>
-            <a:r>
-              <a:t>EXPECTED ANSWERS: Reads through with some hesitation on 'biologist' and 'ninety-two'.</a:t>
-            </a:r>
-          </a:p>
-          <a:p/>
-          <a:p>
-            <a:r>
-              <a:t>COMMON MISTAKES: Skipping the quotation marks and reading dialogue flatly; stumbling on 'biologist'.</a:t>
-            </a:r>
-          </a:p>
-          <a:p/>
-          <a:p>
-            <a:r>
-              <a:t>IF THE STUDENT STRUGGLES (easier step): Read the hard word for them and have them repeat it, then continue.</a:t>
-            </a:r>
-          </a:p>
-          <a:p/>
-          <a:p>
-            <a:r>
-              <a:t>IF THE STUDENT FINISHES FAST (bonus): Ask them to re-read Maya's line with real emotion in the voice.</a:t>
-            </a:r>
-          </a:p>
-          <a:p/>
-          <a:p>
-            <a:r>
-              <a:t>ENCOURAGE: You read that whole page by yourself. That is Grade 5 reading power! ⭐</a:t>
-            </a:r>
-          </a:p>
         </p:txBody>
       </p:sp>
       <p:sp>
@@ -872,53 +734,7 @@
         <p:txBody>
           <a:bodyPr/>
           <a:lstStyle/>
-          <a:p>
-            <a:r>
-              <a:t>⏱ TIMING: 20–25 min</a:t>
-            </a:r>
-          </a:p>
           <a:p/>
-          <a:p>
-            <a:r>
-              <a:t>SAY: Quick challenge! Read these two sentences out loud as smoothly as you can. I'll time you. Then we try again and see if you can beat your own record.</a:t>
-            </a:r>
-          </a:p>
-          <a:p/>
-          <a:p>
-            <a:r>
-              <a:t>HOW TO RUN IT: Time attempt one, celebrate it, then attempt two. Emphasize SMOOTH, not fast — praise expression over speed. Two attempts only, then move on.</a:t>
-            </a:r>
-          </a:p>
-          <a:p/>
-          <a:p>
-            <a:r>
-              <a:t>EXPECTED ANSWERS: Second attempt is usually smoother and 1–3 seconds faster.</a:t>
-            </a:r>
-          </a:p>
-          <a:p/>
-          <a:p>
-            <a:r>
-              <a:t>COMMON MISTAKES: Racing so fast the words blur; ignoring the comma and period pauses.</a:t>
-            </a:r>
-          </a:p>
-          <a:p/>
-          <a:p>
-            <a:r>
-              <a:t>IF THE STUDENT STRUGGLES (easier step): Read it together once first, then let them try solo.</a:t>
-            </a:r>
-          </a:p>
-          <a:p/>
-          <a:p>
-            <a:r>
-              <a:t>IF THE STUDENT FINISHES FAST (bonus): Add a third goal: read it as if you are telling a secret.</a:t>
-            </a:r>
-          </a:p>
-          <a:p/>
-          <a:p>
-            <a:r>
-              <a:t>ENCOURAGE: You beat your own record! That's a streak 🔥 +1 Star ⭐</a:t>
-            </a:r>
-          </a:p>
         </p:txBody>
       </p:sp>
       <p:sp>
@@ -984,53 +800,7 @@
         <p:txBody>
           <a:bodyPr/>
           <a:lstStyle/>
-          <a:p>
-            <a:r>
-              <a:t>⏱ TIMING: 20–25 min</a:t>
-            </a:r>
-          </a:p>
           <a:p/>
-          <a:p>
-            <a:r>
-              <a:t>SAY: Time to be story detectives. These are not test questions — they are clues, and you are allowed to look back at the story any time you want.</a:t>
-            </a:r>
-          </a:p>
-          <a:p/>
-          <a:p>
-            <a:r>
-              <a:t>HOW TO RUN IT: Do the cards one at a time, clockwise. Let the student look back at the passage — that is a reading skill, not cheating. About 60 seconds per card.</a:t>
-            </a:r>
-          </a:p>
-          <a:p/>
-          <a:p>
-            <a:r>
-              <a:t>EXPECTED ANSWERS: b) White light confuses baby turtles  •  FALSE (she built a ramp instead)  •  ninety-two  •  Order: 2, 1, 4, 3</a:t>
-            </a:r>
-          </a:p>
-          <a:p/>
-          <a:p>
-            <a:r>
-              <a:t>COMMON MISTAKES: On the sequence card, mixing up the ramp and the fall; guessing on true/false without checking the text.</a:t>
-            </a:r>
-          </a:p>
-          <a:p/>
-          <a:p>
-            <a:r>
-              <a:t>IF THE STUDENT STRUGGLES (easier step): Narrow it down: 'Was it 9, 92, or 900?' Then re-read that one sentence together.</a:t>
-            </a:r>
-          </a:p>
-          <a:p/>
-          <a:p>
-            <a:r>
-              <a:t>IF THE STUDENT FINISHES FAST (bonus): Ask: 'How do you KNOW that answer? Read me the line that proves it.'</a:t>
-            </a:r>
-          </a:p>
-          <a:p/>
-          <a:p>
-            <a:r>
-              <a:t>ENCOURAGE: You found the proof in the text — that's expert reading! ⭐</a:t>
-            </a:r>
-          </a:p>
         </p:txBody>
       </p:sp>
       <p:sp>
@@ -1096,53 +866,7 @@
         <p:txBody>
           <a:bodyPr/>
           <a:lstStyle/>
-          <a:p>
-            <a:r>
-              <a:t>⏱ TIMING: 20–25 min</a:t>
-            </a:r>
-          </a:p>
           <a:p/>
-          <a:p>
-            <a:r>
-              <a:t>SAY: Round two. These questions need a little more thinking — especially the detective one at the bottom left, where the answer is hidden between the lines.</a:t>
-            </a:r>
-          </a:p>
-          <a:p/>
-          <a:p>
-            <a:r>
-              <a:t>HOW TO RUN IT: Let the student answer in full sentences. For the inference card, give real thinking time — count to five silently before you help.</a:t>
-            </a:r>
-          </a:p>
-          <a:p/>
-          <a:p>
-            <a:r>
-              <a:t>EXPECTED ANSWERS: Problem: three hatchlings were trapped in a deep tire track  •  b)  •  Maya really cares about turtles / Diego knows her well / she always comes back  •  Opinion: any answer with a reason.</a:t>
-            </a:r>
-          </a:p>
-          <a:p/>
-          <a:p>
-            <a:r>
-              <a:t>COMMON MISTAKES: Retelling the whole story instead of naming the main idea; treating the inference question as if the answer is written in the text.</a:t>
-            </a:r>
-          </a:p>
-          <a:p/>
-          <a:p>
-            <a:r>
-              <a:t>IF THE STUDENT STRUGGLES (easier step): For the inference: ask 'Does Diego look surprised? Why not?'</a:t>
-            </a:r>
-          </a:p>
-          <a:p/>
-          <a:p>
-            <a:r>
-              <a:t>IF THE STUDENT FINISHES FAST (bonus): Ask them to invent one more question to ask YOU about the story.</a:t>
-            </a:r>
-          </a:p>
-          <a:p/>
-          <a:p>
-            <a:r>
-              <a:t>ENCOURAGE: You just read BETWEEN the lines. That's a big-kid reading skill! ⭐</a:t>
-            </a:r>
-          </a:p>
         </p:txBody>
       </p:sp>
       <p:sp>
@@ -1208,53 +932,7 @@
         <p:txBody>
           <a:bodyPr/>
           <a:lstStyle/>
-          <a:p>
-            <a:r>
-              <a:t>⏱ TIMING: 20–25 min</a:t>
-            </a:r>
-          </a:p>
           <a:p/>
-          <a:p>
-            <a:r>
-              <a:t>SAY: Match the word on the left to its meaning on the right. Draw a line in the air with your finger, or just say 'one goes with C'.</a:t>
-            </a:r>
-          </a:p>
-          <a:p/>
-          <a:p>
-            <a:r>
-              <a:t>HOW TO RUN IT: Do the first one together as a model, then let the student finish. If they hesitate, read the word and the two most likely meanings only.</a:t>
-            </a:r>
-          </a:p>
-          <a:p/>
-          <a:p>
-            <a:r>
-              <a:t>EXPECTED ANSWERS: 1–C  •  2–E  •  3–A  •  4–B  •  5–D</a:t>
-            </a:r>
-          </a:p>
-          <a:p/>
-          <a:p>
-            <a:r>
-              <a:t>COMMON MISTAKES: Matching 'scramble' with 'survive' because both sound active; guessing by position instead of meaning.</a:t>
-            </a:r>
-          </a:p>
-          <a:p/>
-          <a:p>
-            <a:r>
-              <a:t>IF THE STUDENT STRUGGLES (easier step): Cross out the matches already used so fewer options remain each time.</a:t>
-            </a:r>
-          </a:p>
-          <a:p/>
-          <a:p>
-            <a:r>
-              <a:t>IF THE STUDENT FINISHES FAST (bonus): Ask them to use two of the matched words in a single sentence about the story.</a:t>
-            </a:r>
-          </a:p>
-          <a:p/>
-          <a:p>
-            <a:r>
-              <a:t>ENCOURAGE: Five out of five! Your vocabulary is locked in. ⭐</a:t>
-            </a:r>
-          </a:p>
         </p:txBody>
       </p:sp>
       <p:sp>
@@ -1320,53 +998,7 @@
         <p:txBody>
           <a:bodyPr/>
           <a:lstStyle/>
-          <a:p>
-            <a:r>
-              <a:t>⏱ TIMING: 20–25 min</a:t>
-            </a:r>
-          </a:p>
           <a:p/>
-          <a:p>
-            <a:r>
-              <a:t>SAY: Now you own these words. I'll give you a word and a question, and you answer with a full sentence that uses the word.</a:t>
-            </a:r>
-          </a:p>
-          <a:p/>
-          <a:p>
-            <a:r>
-              <a:t>HOW TO RUN IT: Do two or three prompts, not all four. Let the student finish completely before you say anything. Praise first, then fix at most one thing.</a:t>
-            </a:r>
-          </a:p>
-          <a:p/>
-          <a:p>
-            <a:r>
-              <a:t>EXPECTED ANSWERS: Full sentences, e.g. 'I was exhausted after my soccer game on Saturday.'</a:t>
-            </a:r>
-          </a:p>
-          <a:p/>
-          <a:p>
-            <a:r>
-              <a:t>COMMON MISTAKES: Using the word in the wrong form ('I was exhaust'); answering without the target word.</a:t>
-            </a:r>
-          </a:p>
-          <a:p/>
-          <a:p>
-            <a:r>
-              <a:t>IF THE STUDENT STRUGGLES (easier step): Give them the sentence opening: 'I felt exhausted when...'</a:t>
-            </a:r>
-          </a:p>
-          <a:p/>
-          <a:p>
-            <a:r>
-              <a:t>IF THE STUDENT FINISHES FAST (bonus): Ask them to use the word in a question addressed to you.</a:t>
-            </a:r>
-          </a:p>
-          <a:p/>
-          <a:p>
-            <a:r>
-              <a:t>ENCOURAGE: Perfect use of the word — and a full sentence! +1 Star ⭐</a:t>
-            </a:r>
-          </a:p>
         </p:txBody>
       </p:sp>
       <p:sp>
@@ -1432,53 +1064,7 @@
         <p:txBody>
           <a:bodyPr/>
           <a:lstStyle/>
-          <a:p>
-            <a:r>
-              <a:t>⏱ TIMING: 25–35 min</a:t>
-            </a:r>
-          </a:p>
           <a:p/>
-          <a:p>
-            <a:r>
-              <a:t>SAY: Here is the big secret of tenses: every sentence is standing somewhere on this timeline. Past, now, or future. That's it. Once you can hear WHEN, you can name the tense.</a:t>
-            </a:r>
-          </a:p>
-          <a:p/>
-          <a:p>
-            <a:r>
-              <a:t>HOW TO RUN IT: Walk left to right along the timeline with your hand. Say all three example sentences and have the student repeat them while pointing to the right spot.</a:t>
-            </a:r>
-          </a:p>
-          <a:p/>
-          <a:p>
-            <a:r>
-              <a:t>EXPECTED ANSWERS: Student repeats each sentence and points to the matching part of the timeline.</a:t>
-            </a:r>
-          </a:p>
-          <a:p/>
-          <a:p>
-            <a:r>
-              <a:t>COMMON MISTAKES: Thinking 'tense' means 'nervous'; assuming every past sentence ends in -ed.</a:t>
-            </a:r>
-          </a:p>
-          <a:p/>
-          <a:p>
-            <a:r>
-              <a:t>IF THE STUDENT STRUGGLES (easier step): Use their own life: 'Yesterday I ___', 'Right now I ___', 'Tomorrow I ___'.</a:t>
-            </a:r>
-          </a:p>
-          <a:p/>
-          <a:p>
-            <a:r>
-              <a:t>IF THE STUDENT FINISHES FAST (bonus): Ask them to give one sentence for each spot about their weekend.</a:t>
-            </a:r>
-          </a:p>
-          <a:p/>
-          <a:p>
-            <a:r>
-              <a:t>ENCOURAGE: You just learned what tenses really are in 60 seconds! ⭐</a:t>
-            </a:r>
-          </a:p>
         </p:txBody>
       </p:sp>
       <p:sp>
@@ -1544,53 +1130,7 @@
         <p:txBody>
           <a:bodyPr/>
           <a:lstStyle/>
-          <a:p>
-            <a:r>
-              <a:t>⏱ TIMING: 25–35 min</a:t>
-            </a:r>
-          </a:p>
           <a:p/>
-          <a:p>
-            <a:r>
-              <a:t>SAY: Simple Present is for things that happen again and again — habits and facts. Listen: Maya helps the turtles every August. Every August — it repeats.</a:t>
-            </a:r>
-          </a:p>
-          <a:p/>
-          <a:p>
-            <a:r>
-              <a:t>HOW TO RUN IT: Read the three example rows out loud. Point at the -s in 'helps' and explain it is only for he, she, or it. Keep the whole slide under two minutes.</a:t>
-            </a:r>
-          </a:p>
-          <a:p/>
-          <a:p>
-            <a:r>
-              <a:t>EXPECTED ANSWERS: Student makes a sentence about their own routine, e.g. 'I walk to school every day.'</a:t>
-            </a:r>
-          </a:p>
-          <a:p/>
-          <a:p>
-            <a:r>
-              <a:t>COMMON MISTAKES: Forgetting the -s for he/she/it ('He play soccer'); using 'do' instead of 'does' in questions.</a:t>
-            </a:r>
-          </a:p>
-          <a:p/>
-          <a:p>
-            <a:r>
-              <a:t>IF THE STUDENT STRUGGLES (easier step): Give a fill-in frame: 'Every day I ______.' Let them add just the verb.</a:t>
-            </a:r>
-          </a:p>
-          <a:p/>
-          <a:p>
-            <a:r>
-              <a:t>IF THE STUDENT FINISHES FAST (bonus): Ask them to turn their sentence into a question and a negative.</a:t>
-            </a:r>
-          </a:p>
-          <a:p/>
-          <a:p>
-            <a:r>
-              <a:t>ENCOURAGE: Great — and you remembered the -s! ⭐</a:t>
-            </a:r>
-          </a:p>
         </p:txBody>
       </p:sp>
       <p:sp>
@@ -1656,53 +1196,7 @@
         <p:txBody>
           <a:bodyPr/>
           <a:lstStyle/>
-          <a:p>
-            <a:r>
-              <a:t>⏱ TIMING: 25–35 min</a:t>
-            </a:r>
-          </a:p>
           <a:p/>
-          <a:p>
-            <a:r>
-              <a:t>SAY: Present Continuous is happening RIGHT NOW, this second. The clue is the -ing ending plus a helper word: am, is, or are. Look — I am talking to you right now.</a:t>
-            </a:r>
-          </a:p>
-          <a:p/>
-          <a:p>
-            <a:r>
-              <a:t>HOW TO RUN IT: Act it out. Stand up and say 'I am standing.' Have the student describe what they are doing at this moment. Physical actions make this tense stick.</a:t>
-            </a:r>
-          </a:p>
-          <a:p/>
-          <a:p>
-            <a:r>
-              <a:t>EXPECTED ANSWERS: 'I am sitting at my desk.' / 'I am listening to my teacher.'</a:t>
-            </a:r>
-          </a:p>
-          <a:p/>
-          <a:p>
-            <a:r>
-              <a:t>COMMON MISTAKES: Dropping the helper verb ('I going'); using -ing with feeling verbs ('I am knowing the answer').</a:t>
-            </a:r>
-          </a:p>
-          <a:p/>
-          <a:p>
-            <a:r>
-              <a:t>IF THE STUDENT STRUGGLES (easier step): Point at something you are physically doing and ask 'What am I doing?'</a:t>
-            </a:r>
-          </a:p>
-          <a:p/>
-          <a:p>
-            <a:r>
-              <a:t>IF THE STUDENT FINISHES FAST (bonus): Ask what someone else in their house is doing right now.</a:t>
-            </a:r>
-          </a:p>
-          <a:p/>
-          <a:p>
-            <a:r>
-              <a:t>ENCOURAGE: Perfect — you used 'am' AND '-ing'. That's the full formula! ⭐</a:t>
-            </a:r>
-          </a:p>
         </p:txBody>
       </p:sp>
       <p:sp>
@@ -1768,53 +1262,7 @@
         <p:txBody>
           <a:bodyPr/>
           <a:lstStyle/>
-          <a:p>
-            <a:r>
-              <a:t>⏱ TIMING: 0–5 min</a:t>
-            </a:r>
-          </a:p>
           <a:p/>
-          <a:p>
-            <a:r>
-              <a:t>SAY: Here is our mission map. Eight stops, and you can earn a star at every single one. Nothing lasts long — if something feels tricky, we move on quickly.</a:t>
-            </a:r>
-          </a:p>
-          <a:p/>
-          <a:p>
-            <a:r>
-              <a:t>HOW TO RUN IT: Point to each stop as you read it. Ask the student which stop looks most exciting. Keep it to about 45 seconds.</a:t>
-            </a:r>
-          </a:p>
-          <a:p/>
-          <a:p>
-            <a:r>
-              <a:t>EXPECTED ANSWERS: Student picks a stop, usually the games or storytelling.</a:t>
-            </a:r>
-          </a:p>
-          <a:p/>
-          <a:p>
-            <a:r>
-              <a:t>COMMON MISTAKES: Student may worry about the word 'challenge' or 'quiz'.</a:t>
-            </a:r>
-          </a:p>
-          <a:p/>
-          <a:p>
-            <a:r>
-              <a:t>IF THE STUDENT STRUGGLES (easier step): Reassure: 'The quiz is just a game — I help you the whole time.'</a:t>
-            </a:r>
-          </a:p>
-          <a:p/>
-          <a:p>
-            <a:r>
-              <a:t>IF THE STUDENT FINISHES FAST (bonus): Ask them to predict how many stars they will collect today.</a:t>
-            </a:r>
-          </a:p>
-          <a:p/>
-          <a:p>
-            <a:r>
-              <a:t>ENCOURAGE: Great choice! That one is really fun. ⭐</a:t>
-            </a:r>
-          </a:p>
         </p:txBody>
       </p:sp>
       <p:sp>
@@ -1880,53 +1328,7 @@
         <p:txBody>
           <a:bodyPr/>
           <a:lstStyle/>
-          <a:p>
-            <a:r>
-              <a:t>⏱ TIMING: 25–35 min</a:t>
-            </a:r>
-          </a:p>
           <a:p/>
-          <a:p>
-            <a:r>
-              <a:t>SAY: Simple Past means it started and finished — it is completely over. Most verbs just add -ed, but the sneaky ones change completely: go becomes went, see becomes saw.</a:t>
-            </a:r>
-          </a:p>
-          <a:p/>
-          <a:p>
-            <a:r>
-              <a:t>HOW TO RUN IT: Write three irregular pairs where the student can see them: go/went, eat/ate, see/saw. Ask for one true sentence about their yesterday.</a:t>
-            </a:r>
-          </a:p>
-          <a:p/>
-          <a:p>
-            <a:r>
-              <a:t>EXPECTED ANSWERS: 'I ate pizza last night.' / 'I went to my friend's house.'</a:t>
-            </a:r>
-          </a:p>
-          <a:p/>
-          <a:p>
-            <a:r>
-              <a:t>COMMON MISTAKES: Adding -ed to irregular verbs ('goed', 'eated'); keeping the past verb after 'did' ('I didn't went').</a:t>
-            </a:r>
-          </a:p>
-          <a:p/>
-          <a:p>
-            <a:r>
-              <a:t>IF THE STUDENT STRUGGLES (easier step): Ask a yes/no question first: 'Did you eat breakfast?' Then build the full sentence.</a:t>
-            </a:r>
-          </a:p>
-          <a:p/>
-          <a:p>
-            <a:r>
-              <a:t>IF THE STUDENT FINISHES FAST (bonus): Challenge them to say three past sentences in a row without stopping.</a:t>
-            </a:r>
-          </a:p>
-          <a:p/>
-          <a:p>
-            <a:r>
-              <a:t>ENCOURAGE: You used an irregular verb correctly — those are the hard ones! ⭐</a:t>
-            </a:r>
-          </a:p>
         </p:txBody>
       </p:sp>
       <p:sp>
@@ -1992,53 +1394,7 @@
         <p:txBody>
           <a:bodyPr/>
           <a:lstStyle/>
-          <a:p>
-            <a:r>
-              <a:t>⏱ TIMING: 25–35 min</a:t>
-            </a:r>
-          </a:p>
           <a:p/>
-          <a:p>
-            <a:r>
-              <a:t>SAY: Past Continuous is the movie-scene tense. It was already happening at a moment in the past. At midnight, Maya was counting turtles — the counting was in progress.</a:t>
-            </a:r>
-          </a:p>
-          <a:p/>
-          <a:p>
-            <a:r>
-              <a:t>HOW TO RUN IT: Use the classic interruption pattern: 'I WAS SLEEPING when the phone RANG.' Show the long action and the short action with your hands.</a:t>
-            </a:r>
-          </a:p>
-          <a:p/>
-          <a:p>
-            <a:r>
-              <a:t>EXPECTED ANSWERS: 'I was watching TV when my mom called me.'</a:t>
-            </a:r>
-          </a:p>
-          <a:p/>
-          <a:p>
-            <a:r>
-              <a:t>COMMON MISTAKES: Using 'was' with plural subjects ('they was playing'); confusing this with simple past.</a:t>
-            </a:r>
-          </a:p>
-          <a:p/>
-          <a:p>
-            <a:r>
-              <a:t>IF THE STUDENT STRUGGLES (easier step): Give the frame: 'I was ______ing when ______.' They fill in two blanks only.</a:t>
-            </a:r>
-          </a:p>
-          <a:p/>
-          <a:p>
-            <a:r>
-              <a:t>IF THE STUDENT FINISHES FAST (bonus): Ask them to describe what they were doing at 8 o'clock last night.</a:t>
-            </a:r>
-          </a:p>
-          <a:p/>
-          <a:p>
-            <a:r>
-              <a:t>ENCOURAGE: You built a two-part sentence — that's advanced! ⭐</a:t>
-            </a:r>
-          </a:p>
         </p:txBody>
       </p:sp>
       <p:sp>
@@ -2104,53 +1460,7 @@
         <p:txBody>
           <a:bodyPr/>
           <a:lstStyle/>
-          <a:p>
-            <a:r>
-              <a:t>⏱ TIMING: 25–35 min</a:t>
-            </a:r>
-          </a:p>
           <a:p/>
-          <a:p>
-            <a:r>
-              <a:t>SAY: Simple Future is the easiest one of all. Just add the magic word WILL, and the verb never changes. I will eat. She will eat. They will eat. Same every time!</a:t>
-            </a:r>
-          </a:p>
-          <a:p/>
-          <a:p>
-            <a:r>
-              <a:t>HOW TO RUN IT: Emphasize that 'will' works with every subject — no changes at all. Then ask about their plans for the weekend.</a:t>
-            </a:r>
-          </a:p>
-          <a:p/>
-          <a:p>
-            <a:r>
-              <a:t>EXPECTED ANSWERS: 'I will play video games this weekend.' / 'We will visit my grandma.'</a:t>
-            </a:r>
-          </a:p>
-          <a:p/>
-          <a:p>
-            <a:r>
-              <a:t>COMMON MISTAKES: Adding -s after will ('He will plays'); using present tense for future plans.</a:t>
-            </a:r>
-          </a:p>
-          <a:p/>
-          <a:p>
-            <a:r>
-              <a:t>IF THE STUDENT STRUGGLES (easier step): Ask a simple question: 'What will you eat for dinner tonight?'</a:t>
-            </a:r>
-          </a:p>
-          <a:p/>
-          <a:p>
-            <a:r>
-              <a:t>IF THE STUDENT FINISHES FAST (bonus): Ask them to predict three things about next year.</a:t>
-            </a:r>
-          </a:p>
-          <a:p/>
-          <a:p>
-            <a:r>
-              <a:t>ENCOURAGE: 'Will' never changes — and you got that right away! ⭐</a:t>
-            </a:r>
-          </a:p>
         </p:txBody>
       </p:sp>
       <p:sp>
@@ -2216,53 +1526,7 @@
         <p:txBody>
           <a:bodyPr/>
           <a:lstStyle/>
-          <a:p>
-            <a:r>
-              <a:t>⏱ TIMING: 25–35 min</a:t>
-            </a:r>
-          </a:p>
           <a:p/>
-          <a:p>
-            <a:r>
-              <a:t>SAY: Here they all are on one map. You do not have to memorize this — just remember the three shortcuts at the bottom. Those three clues will get you the right answer almost every time.</a:t>
-            </a:r>
-          </a:p>
-          <a:p/>
-          <a:p>
-            <a:r>
-              <a:t>HOW TO RUN IT: Read the shortcut line slowly and let the student repeat it. Then point to a random box and ask them to say the example sentence.</a:t>
-            </a:r>
-          </a:p>
-          <a:p/>
-          <a:p>
-            <a:r>
-              <a:t>EXPECTED ANSWERS: Student reads any example sentence and can explain one shortcut in their own words.</a:t>
-            </a:r>
-          </a:p>
-          <a:p/>
-          <a:p>
-            <a:r>
-              <a:t>COMMON MISTAKES: Feeling overwhelmed by five boxes at once.</a:t>
-            </a:r>
-          </a:p>
-          <a:p/>
-          <a:p>
-            <a:r>
-              <a:t>IF THE STUDENT STRUGGLES (easier step): Cover three boxes with your hand and work with only two at a time.</a:t>
-            </a:r>
-          </a:p>
-          <a:p/>
-          <a:p>
-            <a:r>
-              <a:t>IF THE STUDENT FINISHES FAST (bonus): Point at a box and ask them to make a NEW sentence in that tense.</a:t>
-            </a:r>
-          </a:p>
-          <a:p/>
-          <a:p>
-            <a:r>
-              <a:t>ENCOURAGE: Five tenses, one map, and you can read it. Amazing! ⭐</a:t>
-            </a:r>
-          </a:p>
         </p:txBody>
       </p:sp>
       <p:sp>
@@ -2328,53 +1592,7 @@
         <p:txBody>
           <a:bodyPr/>
           <a:lstStyle/>
-          <a:p>
-            <a:r>
-              <a:t>⏱ TIMING: 35–47 min</a:t>
-            </a:r>
-          </a:p>
           <a:p/>
-          <a:p>
-            <a:r>
-              <a:t>SAY: Detective badge on! Every sentence has a signal word that gives away the tense. Find the signal first, then name the tense. I put the clue in small gray letters to help you.</a:t>
-            </a:r>
-          </a:p>
-          <a:p/>
-          <a:p>
-            <a:r>
-              <a:t>HOW TO RUN IT: Do sentence 1 together as a model. Then let the student work through the rest. Move fast — about 15 seconds each. Celebrate every catch.</a:t>
-            </a:r>
-          </a:p>
-          <a:p/>
-          <a:p>
-            <a:r>
-              <a:t>EXPECTED ANSWERS: 1 Simple Past  •  2 Present Continuous  •  3 Simple Future  •  4 Simple Present  •  5 Past Continuous  •  6 Simple Present</a:t>
-            </a:r>
-          </a:p>
-          <a:p/>
-          <a:p>
-            <a:r>
-              <a:t>COMMON MISTAKES: Calling number 5 simple past because it happened in the past; missing that number 6 is present because of 'does'.</a:t>
-            </a:r>
-          </a:p>
-          <a:p/>
-          <a:p>
-            <a:r>
-              <a:t>IF THE STUDENT STRUGGLES (easier step): Ask only 'Past, present, or future?' first, then narrow to the exact name.</a:t>
-            </a:r>
-          </a:p>
-          <a:p/>
-          <a:p>
-            <a:r>
-              <a:t>IF THE STUDENT FINISHES FAST (bonus): Ask them to change sentence 1 into all five tenses.</a:t>
-            </a:r>
-          </a:p>
-          <a:p/>
-          <a:p>
-            <a:r>
-              <a:t>ENCOURAGE: Six for six! You are officially a Tense Detective 🕵️ ⭐</a:t>
-            </a:r>
-          </a:p>
         </p:txBody>
       </p:sp>
       <p:sp>
@@ -2440,53 +1658,7 @@
         <p:txBody>
           <a:bodyPr/>
           <a:lstStyle/>
-          <a:p>
-            <a:r>
-              <a:t>⏱ TIMING: 35–47 min</a:t>
-            </a:r>
-          </a:p>
           <a:p/>
-          <a:p>
-            <a:r>
-              <a:t>SAY: These sentences are broken, and you are the repair crew. Each one has exactly one mistake. Read it out loud first — your ear will often catch it before your eyes do.</a:t>
-            </a:r>
-          </a:p>
-          <a:p/>
-          <a:p>
-            <a:r>
-              <a:t>HOW TO RUN IT: Have the student read the broken sentence aloud, then say the fixed version as a complete sentence. Do not just accept the single word.</a:t>
-            </a:r>
-          </a:p>
-          <a:p/>
-          <a:p>
-            <a:r>
-              <a:t>EXPECTED ANSWERS: 1 went  •  2 is reading  •  3 will go  •  4 didn't go  •  5 I know  •  6 was ringing</a:t>
-            </a:r>
-          </a:p>
-          <a:p/>
-          <a:p>
-            <a:r>
-              <a:t>COMMON MISTAKES: Fixing only part of it ('goes' → 'go' without adding 'will'); missing that 'know' cannot take -ing.</a:t>
-            </a:r>
-          </a:p>
-          <a:p/>
-          <a:p>
-            <a:r>
-              <a:t>IF THE STUDENT STRUGGLES (easier step): Read both versions aloud yourself and ask 'Which one sounds right?'</a:t>
-            </a:r>
-          </a:p>
-          <a:p/>
-          <a:p>
-            <a:r>
-              <a:t>IF THE STUDENT FINISHES FAST (bonus): Ask them to explain WHY the fix works, using the signal word.</a:t>
-            </a:r>
-          </a:p>
-          <a:p/>
-          <a:p>
-            <a:r>
-              <a:t>ENCOURAGE: You heard the mistake by yourself — that's a real English ear! ⭐</a:t>
-            </a:r>
-          </a:p>
         </p:txBody>
       </p:sp>
       <p:sp>
@@ -2552,53 +1724,7 @@
         <p:txBody>
           <a:bodyPr/>
           <a:lstStyle/>
-          <a:p>
-            <a:r>
-              <a:t>⏱ TIMING: 35–47 min</a:t>
-            </a:r>
-          </a:p>
           <a:p/>
-          <a:p>
-            <a:r>
-              <a:t>SAY: Two quick games side by side. On the left, you are a time traveler — take one sentence and move it through yesterday, today, and tomorrow. On the right, sort each sentence into past, now, or future.</a:t>
-            </a:r>
-          </a:p>
-          <a:p/>
-          <a:p>
-            <a:r>
-              <a:t>HOW TO RUN IT: Do the left game first, out loud, all three versions. Then switch to sorting. Keep each game to about three minutes so it stays fresh.</a:t>
-            </a:r>
-          </a:p>
-          <a:p/>
-          <a:p>
-            <a:r>
-              <a:t>EXPECTED ANSWERS: Time Travel: helped / is helping / will help.  Sorting: F, P, N, N, P, N</a:t>
-            </a:r>
-          </a:p>
-          <a:p/>
-          <a:p>
-            <a:r>
-              <a:t>COMMON MISTAKES: Saying 'Maya will helps'; sorting 'I was reading' as present because of -ing.</a:t>
-            </a:r>
-          </a:p>
-          <a:p/>
-          <a:p>
-            <a:r>
-              <a:t>IF THE STUDENT STRUGGLES (easier step): For sorting, ask only 'Did it already happen? Yes or no?' first.</a:t>
-            </a:r>
-          </a:p>
-          <a:p/>
-          <a:p>
-            <a:r>
-              <a:t>IF THE STUDENT FINISHES FAST (bonus): Ask them to invent a fourth version: 'What was Maya doing at midnight?'</a:t>
-            </a:r>
-          </a:p>
-          <a:p/>
-          <a:p>
-            <a:r>
-              <a:t>ENCOURAGE: You moved that sentence through time perfectly! 🔥 ⭐</a:t>
-            </a:r>
-          </a:p>
         </p:txBody>
       </p:sp>
       <p:sp>
@@ -2664,53 +1790,7 @@
         <p:txBody>
           <a:bodyPr/>
           <a:lstStyle/>
-          <a:p>
-            <a:r>
-              <a:t>⏱ TIMING: 35–47 min</a:t>
-            </a:r>
-          </a:p>
           <a:p/>
-          <a:p>
-            <a:r>
-              <a:t>SAY: Left side: pick the right word. Right side: the sprint! I will start the timer and you name as many tenses as you can in 60 seconds. Ready?</a:t>
-            </a:r>
-          </a:p>
-          <a:p/>
-          <a:p>
-            <a:r>
-              <a:t>HOW TO RUN IT: Do the four multiple-choice items calmly first. Then make the sprint genuinely exciting — count down, keep score out loud, and cheer.</a:t>
-            </a:r>
-          </a:p>
-          <a:p/>
-          <a:p>
-            <a:r>
-              <a:t>EXPECTED ANSWERS: Complete: 1c will go  •  2b is doing  •  3c ate  •  4a plays.  Sprint: past, present continuous, future, present, past continuous, present, future, past continuous.</a:t>
-            </a:r>
-          </a:p>
-          <a:p/>
-          <a:p>
-            <a:r>
-              <a:t>COMMON MISTAKES: In the sprint, rushing and saying 'past' for anything with was/were.</a:t>
-            </a:r>
-          </a:p>
-          <a:p/>
-          <a:p>
-            <a:r>
-              <a:t>IF THE STUDENT STRUGGLES (easier step): Slow the sprint down and do only four sentences with no timer.</a:t>
-            </a:r>
-          </a:p>
-          <a:p/>
-          <a:p>
-            <a:r>
-              <a:t>IF THE STUDENT FINISHES FAST (bonus): Run the sprint a second time and try to beat the first score.</a:t>
-            </a:r>
-          </a:p>
-          <a:p/>
-          <a:p>
-            <a:r>
-              <a:t>ENCOURAGE: You beat the clock! That's a streak 🔥 +1 Star ⭐</a:t>
-            </a:r>
-          </a:p>
         </p:txBody>
       </p:sp>
       <p:sp>
@@ -2776,53 +1856,7 @@
         <p:txBody>
           <a:bodyPr/>
           <a:lstStyle/>
-          <a:p>
-            <a:r>
-              <a:t>⏱ TIMING: 47–55 min</a:t>
-            </a:r>
-          </a:p>
           <a:p/>
-          <a:p>
-            <a:r>
-              <a:t>SAY: Now YOU are the author. Look at these four pictures and build a story. Use the five prompts to keep it organized, and try to use a past, a present, and a future sentence somewhere in your story.</a:t>
-            </a:r>
-          </a:p>
-          <a:p/>
-          <a:p>
-            <a:r>
-              <a:t>HOW TO RUN IT: Let the student talk for 2–3 minutes without interruption. Take quick notes on tense use. Do not correct while they are speaking — it breaks their flow completely.</a:t>
-            </a:r>
-          </a:p>
-          <a:p/>
-          <a:p>
-            <a:r>
-              <a:t>EXPECTED ANSWERS: A 5–8 sentence story that moves through the four pictures with at least two tenses used.</a:t>
-            </a:r>
-          </a:p>
-          <a:p/>
-          <a:p>
-            <a:r>
-              <a:t>COMMON MISTAKES: Telling the whole story in present tense; describing pictures separately instead of connecting them into one story.</a:t>
-            </a:r>
-          </a:p>
-          <a:p/>
-          <a:p>
-            <a:r>
-              <a:t>IF THE STUDENT STRUGGLES (easier step): Point to picture 1 and ask just 'Who is this and where are they?' Build it one picture at a time.</a:t>
-            </a:r>
-          </a:p>
-          <a:p/>
-          <a:p>
-            <a:r>
-              <a:t>IF THE STUDENT FINISHES FAST (bonus): Ask them to add a surprise twist to the ending.</a:t>
-            </a:r>
-          </a:p>
-          <a:p/>
-          <a:p>
-            <a:r>
-              <a:t>ENCOURAGE: What a storyteller! I could picture the whole thing. +1 Star ⭐</a:t>
-            </a:r>
-          </a:p>
         </p:txBody>
       </p:sp>
       <p:sp>
@@ -2888,53 +1922,7 @@
         <p:txBody>
           <a:bodyPr/>
           <a:lstStyle/>
-          <a:p>
-            <a:r>
-              <a:t>⏱ TIMING: 47–55 min</a:t>
-            </a:r>
-          </a:p>
           <a:p/>
-          <a:p>
-            <a:r>
-              <a:t>SAY: Four questions, and each one secretly needs a different tense. Answer in as many sentences as you like. I am going to listen the whole way through and I will not interrupt you.</a:t>
-            </a:r>
-          </a:p>
-          <a:p/>
-          <a:p>
-            <a:r>
-              <a:t>HOW TO RUN IT: Ask all four. Let the student finish completely each time. Then: praise something specific first, correct at most two things, and have them repeat the corrected sentence once.</a:t>
-            </a:r>
-          </a:p>
-          <a:p/>
-          <a:p>
-            <a:r>
-              <a:t>EXPECTED ANSWERS: Yesterday → past forms; today → am/is/are + -ing; weekends → present; this weekend → will.</a:t>
-            </a:r>
-          </a:p>
-          <a:p/>
-          <a:p>
-            <a:r>
-              <a:t>COMMON MISTAKES: Using present tense for the 'yesterday' question; forgetting 'will' for the last one.</a:t>
-            </a:r>
-          </a:p>
-          <a:p/>
-          <a:p>
-            <a:r>
-              <a:t>IF THE STUDENT STRUGGLES (easier step): Answer the question yourself first as a model, then ask them again.</a:t>
-            </a:r>
-          </a:p>
-          <a:p/>
-          <a:p>
-            <a:r>
-              <a:t>IF THE STUDENT FINISHES FAST (bonus): Ask a follow-up: 'Why?' or 'Who will be with you?'</a:t>
-            </a:r>
-          </a:p>
-          <a:p/>
-          <a:p>
-            <a:r>
-              <a:t>ENCOURAGE: You used four different tenses without me telling you. That's real English! ⭐</a:t>
-            </a:r>
-          </a:p>
         </p:txBody>
       </p:sp>
       <p:sp>
@@ -3000,53 +1988,7 @@
         <p:txBody>
           <a:bodyPr/>
           <a:lstStyle/>
-          <a:p>
-            <a:r>
-              <a:t>⏱ TIMING: 0–5 min</a:t>
-            </a:r>
-          </a:p>
           <a:p/>
-          <a:p>
-            <a:r>
-              <a:t>SAY: Let's warm up our talking muscles. I will read two choices and you pick one — but you have to tell me WHY. I'll go first: I would rather swim with sea turtles because I love the ocean.</a:t>
-            </a:r>
-          </a:p>
-          <a:p/>
-          <a:p>
-            <a:r>
-              <a:t>HOW TO RUN IT: Model the first one yourself, then do 3–4 pairs with the student. Do not do all six unless the student is enjoying it. Stop while it is still fun.</a:t>
-            </a:r>
-          </a:p>
-          <a:p/>
-          <a:p>
-            <a:r>
-              <a:t>EXPECTED ANSWERS: Full sentence with 'because' — e.g. 'I would rather fly with eagles because I want to see the mountains.'</a:t>
-            </a:r>
-          </a:p>
-          <a:p/>
-          <a:p>
-            <a:r>
-              <a:t>COMMON MISTAKES: Answering with just one word ('dragon') and leaving out 'because'.</a:t>
-            </a:r>
-          </a:p>
-          <a:p/>
-          <a:p>
-            <a:r>
-              <a:t>IF THE STUDENT STRUGGLES (easier step): Give a sentence frame out loud and let them finish it: 'I would rather ___ because ___.'</a:t>
-            </a:r>
-          </a:p>
-          <a:p/>
-          <a:p>
-            <a:r>
-              <a:t>IF THE STUDENT FINISHES FAST (bonus): Ask a follow-up: 'What is one BAD thing about your choice?'</a:t>
-            </a:r>
-          </a:p>
-          <a:p/>
-          <a:p>
-            <a:r>
-              <a:t>ENCOURAGE: I love that reason — full sentence too! +1 Star ⭐</a:t>
-            </a:r>
-          </a:p>
         </p:txBody>
       </p:sp>
       <p:sp>
@@ -3112,53 +2054,7 @@
         <p:txBody>
           <a:bodyPr/>
           <a:lstStyle/>
-          <a:p>
-            <a:r>
-              <a:t>⏱ TIMING: 55–58 min</a:t>
-            </a:r>
-          </a:p>
           <a:p/>
-          <a:p>
-            <a:r>
-              <a:t>SAY: Last challenge of the day! Six quick questions that cover everything we did. Remember — this is a game. If you want a hint, just ask and you still get the star.</a:t>
-            </a:r>
-          </a:p>
-          <a:p/>
-          <a:p>
-            <a:r>
-              <a:t>HOW TO RUN IT: Move quickly, roughly 20 seconds per item. Give hints freely. The goal is a confident finish, not a hard assessment.</a:t>
-            </a:r>
-          </a:p>
-          <a:p/>
-          <a:p>
-            <a:r>
-              <a:t>EXPECTED ANSWERS: 1 watched  •  2 I am running  •  3 very tired  •  4 He doesn't like fish  •  5 So the trapped hatchlings could climb out by themselves  •  6 any correct 'will' sentence.</a:t>
-            </a:r>
-          </a:p>
-          <a:p/>
-          <a:p>
-            <a:r>
-              <a:t>COMMON MISTAKES: Rushing question 4 and only fixing 'don't' to 'not'; forgetting 'will' in question 6.</a:t>
-            </a:r>
-          </a:p>
-          <a:p/>
-          <a:p>
-            <a:r>
-              <a:t>IF THE STUDENT STRUGGLES (easier step): Turn any item into a two-choice question instead of three.</a:t>
-            </a:r>
-          </a:p>
-          <a:p/>
-          <a:p>
-            <a:r>
-              <a:t>IF THE STUDENT FINISHES FAST (bonus): Ask them to write one more question to quiz YOU with.</a:t>
-            </a:r>
-          </a:p>
-          <a:p/>
-          <a:p>
-            <a:r>
-              <a:t>ENCOURAGE: Look at that — you finished the whole challenge! 🏆 ⭐</a:t>
-            </a:r>
-          </a:p>
         </p:txBody>
       </p:sp>
       <p:sp>
@@ -3224,53 +2120,7 @@
         <p:txBody>
           <a:bodyPr/>
           <a:lstStyle/>
-          <a:p>
-            <a:r>
-              <a:t>⏱ TIMING: 58–60 min</a:t>
-            </a:r>
-          </a:p>
           <a:p/>
-          <a:p>
-            <a:r>
-              <a:t>SAY: Look at everything you did in one hour. Six different skills. When you started you had not read the story yet, and now you can tell me all five tenses.</a:t>
-            </a:r>
-          </a:p>
-          <a:p/>
-          <a:p>
-            <a:r>
-              <a:t>HOW TO RUN IT: Point to each card and let the student say what they remember about it. Keep it celebratory and quick — about 45 seconds total.</a:t>
-            </a:r>
-          </a:p>
-          <a:p/>
-          <a:p>
-            <a:r>
-              <a:t>EXPECTED ANSWERS: Student recalls the story name, a few vocabulary words, and at least two tenses.</a:t>
-            </a:r>
-          </a:p>
-          <a:p/>
-          <a:p>
-            <a:r>
-              <a:t>COMMON MISTAKES: Being modest or saying they don't remember.</a:t>
-            </a:r>
-          </a:p>
-          <a:p/>
-          <a:p>
-            <a:r>
-              <a:t>IF THE STUDENT STRUGGLES (easier step): Prompt with the first sound: 'The story was about a t...?'</a:t>
-            </a:r>
-          </a:p>
-          <a:p/>
-          <a:p>
-            <a:r>
-              <a:t>IF THE STUDENT FINISHES FAST (bonus): Ask which skill they want to practice more next time.</a:t>
-            </a:r>
-          </a:p>
-          <a:p/>
-          <a:p>
-            <a:r>
-              <a:t>ENCOURAGE: You should be really proud of this. I am! 🏆</a:t>
-            </a:r>
-          </a:p>
         </p:txBody>
       </p:sp>
       <p:sp>
@@ -3336,53 +2186,7 @@
         <p:txBody>
           <a:bodyPr/>
           <a:lstStyle/>
-          <a:p>
-            <a:r>
-              <a:t>⏱ TIMING: 58–60 min</a:t>
-            </a:r>
-          </a:p>
           <a:p/>
-          <a:p>
-            <a:r>
-              <a:t>SAY: Last thing before your reward. Tell me honestly how each part felt. If something is still tricky, that is really useful for me to know — it helps me teach you better.</a:t>
-            </a:r>
-          </a:p>
-          <a:p/>
-          <a:p>
-            <a:r>
-              <a:t>HOW TO RUN IT: Go through all four rows quickly. Genuinely thank them for any honest 'still tricky' answer so honesty feels safe.</a:t>
-            </a:r>
-          </a:p>
-          <a:p/>
-          <a:p>
-            <a:r>
-              <a:t>EXPECTED ANSWERS: Honest self-ratings plus one favorite activity named.</a:t>
-            </a:r>
-          </a:p>
-          <a:p/>
-          <a:p>
-            <a:r>
-              <a:t>COMMON MISTAKES: Rating everything as 'I've got this' to please the teacher.</a:t>
-            </a:r>
-          </a:p>
-          <a:p/>
-          <a:p>
-            <a:r>
-              <a:t>IF THE STUDENT STRUGGLES (easier step): Ask instead: 'Which one would you like to play again next time?'</a:t>
-            </a:r>
-          </a:p>
-          <a:p/>
-          <a:p>
-            <a:r>
-              <a:t>IF THE STUDENT FINISHES FAST (bonus): Ask what they would like to learn in the next class.</a:t>
-            </a:r>
-          </a:p>
-          <a:p/>
-          <a:p>
-            <a:r>
-              <a:t>ENCOURAGE: Thank you for being honest — that is how we get better. 💛</a:t>
-            </a:r>
-          </a:p>
         </p:txBody>
       </p:sp>
       <p:sp>
@@ -3448,53 +2252,7 @@
         <p:txBody>
           <a:bodyPr/>
           <a:lstStyle/>
-          <a:p>
-            <a:r>
-              <a:t>⏱ TIMING: 58–60 min</a:t>
-            </a:r>
-          </a:p>
           <a:p/>
-          <a:p>
-            <a:r>
-              <a:t>SAY: This is optional — pick just one that sounds fun. My favorite is telling the turtle story to someone at home, because teaching someone else is the fastest way to remember something.</a:t>
-            </a:r>
-          </a:p>
-          <a:p/>
-          <a:p>
-            <a:r>
-              <a:t>HOW TO RUN IT: Let the student choose out loud so they own the decision. Never assign all four.</a:t>
-            </a:r>
-          </a:p>
-          <a:p/>
-          <a:p>
-            <a:r>
-              <a:t>EXPECTED ANSWERS: Student picks one task and says when they will do it.</a:t>
-            </a:r>
-          </a:p>
-          <a:p/>
-          <a:p>
-            <a:r>
-              <a:t>COMMON MISTAKES: Feeling pressured to do all four, or seeing this as real homework.</a:t>
-            </a:r>
-          </a:p>
-          <a:p/>
-          <a:p>
-            <a:r>
-              <a:t>IF THE STUDENT STRUGGLES (easier step): Say clearly: 'Zero is also fine. This is a bonus, not a rule.'</a:t>
-            </a:r>
-          </a:p>
-          <a:p/>
-          <a:p>
-            <a:r>
-              <a:t>IF THE STUDENT FINISHES FAST (bonus): Invite them to bring their drawing or sentences to the next class.</a:t>
-            </a:r>
-          </a:p>
-          <a:p/>
-          <a:p>
-            <a:r>
-              <a:t>ENCOURAGE: Great pick — I can't wait to hear about it! 🎁</a:t>
-            </a:r>
-          </a:p>
         </p:txBody>
       </p:sp>
       <p:sp>
@@ -3560,53 +2318,7 @@
         <p:txBody>
           <a:bodyPr/>
           <a:lstStyle/>
-          <a:p>
-            <a:r>
-              <a:t>⏱ TIMING: 58–60 min</a:t>
-            </a:r>
-          </a:p>
           <a:p/>
-          <a:p>
-            <a:r>
-              <a:t>SAY: You did it! Look at that trophy — you earned every bit of it. You read, you played, you told your own story, and you spoke English for a whole hour. I am really proud of you, and I can't wait for our next adventure.</a:t>
-            </a:r>
-          </a:p>
-          <a:p/>
-          <a:p>
-            <a:r>
-              <a:t>HOW TO RUN IT: End on maximum energy. Applaud, give a virtual high five, and say one specific thing they did well today so the praise feels real and personal.</a:t>
-            </a:r>
-          </a:p>
-          <a:p/>
-          <a:p>
-            <a:r>
-              <a:t>EXPECTED ANSWERS: Student smiles, says thank you, and often asks when the next class is.</a:t>
-            </a:r>
-          </a:p>
-          <a:p/>
-          <a:p>
-            <a:r>
-              <a:t>COMMON MISTAKES: Rushing off before the celebration lands.</a:t>
-            </a:r>
-          </a:p>
-          <a:p/>
-          <a:p>
-            <a:r>
-              <a:t>IF THE STUDENT STRUGGLES (easier step): If they seem shy about praise, just name one concrete fact: 'You read 300 words out loud.'</a:t>
-            </a:r>
-          </a:p>
-          <a:p/>
-          <a:p>
-            <a:r>
-              <a:t>IF THE STUDENT FINISHES FAST (bonus): Ask what adventure they want next time — space, animals, or mystery?</a:t>
-            </a:r>
-          </a:p>
-          <a:p/>
-          <a:p>
-            <a:r>
-              <a:t>ENCOURAGE: You were fantastic today. See you next time, adventurer! 🏆⭐</a:t>
-            </a:r>
-          </a:p>
         </p:txBody>
       </p:sp>
       <p:sp>
@@ -3672,53 +2384,7 @@
         <p:txBody>
           <a:bodyPr/>
           <a:lstStyle/>
-          <a:p>
-            <a:r>
-              <a:t>⏱ TIMING: After class</a:t>
-            </a:r>
-          </a:p>
           <a:p/>
-          <a:p>
-            <a:r>
-              <a:t>SAY: TEACHER SLIDE — do not display to the student.</a:t>
-            </a:r>
-          </a:p>
-          <a:p/>
-          <a:p>
-            <a:r>
-              <a:t>HOW TO RUN IT: Complete this within five minutes of finishing the class, while details are fresh. Circle one star rating per skill and add one short note.</a:t>
-            </a:r>
-          </a:p>
-          <a:p/>
-          <a:p>
-            <a:r>
-              <a:t>EXPECTED ANSWERS: Most first-demo Grade 5 students land at 3 stars for grammar and 3–4 for participation.</a:t>
-            </a:r>
-          </a:p>
-          <a:p/>
-          <a:p>
-            <a:r>
-              <a:t>COMMON MISTAKES: Rating too harshly on a first demo, which discourages both student and parent.</a:t>
-            </a:r>
-          </a:p>
-          <a:p/>
-          <a:p>
-            <a:r>
-              <a:t>IF THE STUDENT STRUGGLES (easier step): If unsure between two levels, choose the higher one and note what to watch next time.</a:t>
-            </a:r>
-          </a:p>
-          <a:p/>
-          <a:p>
-            <a:r>
-              <a:t>IF THE STUDENT FINISHES FAST (bonus): Add one specific next-step goal per skill for the follow-up lesson.</a:t>
-            </a:r>
-          </a:p>
-          <a:p/>
-          <a:p>
-            <a:r>
-              <a:t>ENCOURAGE: Frame all feedback to parents as strengths first, then one growth area.</a:t>
-            </a:r>
-          </a:p>
         </p:txBody>
       </p:sp>
       <p:sp>
@@ -3784,53 +2450,7 @@
         <p:txBody>
           <a:bodyPr/>
           <a:lstStyle/>
-          <a:p>
-            <a:r>
-              <a:t>⏱ TIMING: Reference</a:t>
-            </a:r>
-          </a:p>
           <a:p/>
-          <a:p>
-            <a:r>
-              <a:t>SAY: TEACHER SLIDE — answer key for reading and vocabulary.</a:t>
-            </a:r>
-          </a:p>
-          <a:p/>
-          <a:p>
-            <a:r>
-              <a:t>HOW TO RUN IT: Hide this slide in PowerPoint (right-click the thumbnail → Hide Slide) before you present, or keep it open on a second screen.</a:t>
-            </a:r>
-          </a:p>
-          <a:p/>
-          <a:p>
-            <a:r>
-              <a:t>EXPECTED ANSWERS: See the slide content for all answers.</a:t>
-            </a:r>
-          </a:p>
-          <a:p/>
-          <a:p>
-            <a:r>
-              <a:t>COMMON MISTAKES: Accidentally presenting this slide to the student.</a:t>
-            </a:r>
-          </a:p>
-          <a:p/>
-          <a:p>
-            <a:r>
-              <a:t>IF THE STUDENT STRUGGLES (easier step): Accept any reasonable wording for short-answer and opinion items.</a:t>
-            </a:r>
-          </a:p>
-          <a:p/>
-          <a:p>
-            <a:r>
-              <a:t>IF THE STUDENT FINISHES FAST (bonus): For fast finishers, ask them to justify each answer with a line from the text.</a:t>
-            </a:r>
-          </a:p>
-          <a:p/>
-          <a:p>
-            <a:r>
-              <a:t>ENCOURAGE: Reference only.</a:t>
-            </a:r>
-          </a:p>
         </p:txBody>
       </p:sp>
       <p:sp>
@@ -3896,53 +2516,7 @@
         <p:txBody>
           <a:bodyPr/>
           <a:lstStyle/>
-          <a:p>
-            <a:r>
-              <a:t>⏱ TIMING: Reference</a:t>
-            </a:r>
-          </a:p>
           <a:p/>
-          <a:p>
-            <a:r>
-              <a:t>SAY: TEACHER SLIDE — answer key for all grammar and tense games.</a:t>
-            </a:r>
-          </a:p>
-          <a:p/>
-          <a:p>
-            <a:r>
-              <a:t>HOW TO RUN IT: Hide this slide before presenting. Keep it handy during the tense games so you can confirm answers instantly without losing pace.</a:t>
-            </a:r>
-          </a:p>
-          <a:p/>
-          <a:p>
-            <a:r>
-              <a:t>EXPECTED ANSWERS: See the slide content for all answers.</a:t>
-            </a:r>
-          </a:p>
-          <a:p/>
-          <a:p>
-            <a:r>
-              <a:t>COMMON MISTAKES: Correcting a student answer that is actually acceptable — several items allow more than one correct phrasing.</a:t>
-            </a:r>
-          </a:p>
-          <a:p/>
-          <a:p>
-            <a:r>
-              <a:t>IF THE STUDENT STRUGGLES (easier step): If the student produces a different but grammatically correct sentence, accept it and praise the creativity.</a:t>
-            </a:r>
-          </a:p>
-          <a:p/>
-          <a:p>
-            <a:r>
-              <a:t>IF THE STUDENT FINISHES FAST (bonus): Use the sprint list again as a warm-up at the start of the next lesson.</a:t>
-            </a:r>
-          </a:p>
-          <a:p/>
-          <a:p>
-            <a:r>
-              <a:t>ENCOURAGE: Reference only.</a:t>
-            </a:r>
-          </a:p>
         </p:txBody>
       </p:sp>
       <p:sp>
@@ -4008,53 +2582,7 @@
         <p:txBody>
           <a:bodyPr/>
           <a:lstStyle/>
-          <a:p>
-            <a:r>
-              <a:t>⏱ TIMING: 5–10 min</a:t>
-            </a:r>
-          </a:p>
           <a:p/>
-          <a:p>
-            <a:r>
-              <a:t>SAY: These six words come from our story. I will say each word, you say it back, then I'll tell you what it means. Repeat after me: hatched... volunteer...</a:t>
-            </a:r>
-          </a:p>
-          <a:p/>
-          <a:p>
-            <a:r>
-              <a:t>HOW TO RUN IT: Choral repeat each word once. Read the meaning, not the whole card. Spend about 20 seconds per word. Then ask for one student sentence using any word.</a:t>
-            </a:r>
-          </a:p>
-          <a:p/>
-          <a:p>
-            <a:r>
-              <a:t>EXPECTED ANSWERS: Clear repetition; one original sentence such as 'The bird hatched from the egg.'</a:t>
-            </a:r>
-          </a:p>
-          <a:p/>
-          <a:p>
-            <a:r>
-              <a:t>COMMON MISTAKES: Stress on the wrong syllable in 'biologist' and 'exhausted'; confusing 'hatched' with 'hatchling'.</a:t>
-            </a:r>
-          </a:p>
-          <a:p/>
-          <a:p>
-            <a:r>
-              <a:t>IF THE STUDENT STRUGGLES (easier step): Break the word into parts and clap the syllables: ex-HAUS-ted.</a:t>
-            </a:r>
-          </a:p>
-          <a:p/>
-          <a:p>
-            <a:r>
-              <a:t>IF THE STUDENT FINISHES FAST (bonus): Ask them to use TWO words in one sentence.</a:t>
-            </a:r>
-          </a:p>
-          <a:p/>
-          <a:p>
-            <a:r>
-              <a:t>ENCOURAGE: Your pronunciation is getting better every time! ⭐</a:t>
-            </a:r>
-          </a:p>
         </p:txBody>
       </p:sp>
       <p:sp>
@@ -4120,53 +2648,7 @@
         <p:txBody>
           <a:bodyPr/>
           <a:lstStyle/>
-          <a:p>
-            <a:r>
-              <a:t>⏱ TIMING: 5–10 min</a:t>
-            </a:r>
-          </a:p>
           <a:p/>
-          <a:p>
-            <a:r>
-              <a:t>SAY: Six more words. These are the tricky ones — but you are going to own them. Repeat after me: biologist... survive... journey...</a:t>
-            </a:r>
-          </a:p>
-          <a:p/>
-          <a:p>
-            <a:r>
-              <a:t>HOW TO RUN IT: Same routine as the previous slide. Keep it brisk. If the student is fading, do only four words and move to the game.</a:t>
-            </a:r>
-          </a:p>
-          <a:p/>
-          <a:p>
-            <a:r>
-              <a:t>EXPECTED ANSWERS: Accurate repetition; student picks a favorite word and says it three times.</a:t>
-            </a:r>
-          </a:p>
-          <a:p/>
-          <a:p>
-            <a:r>
-              <a:t>COMMON MISTAKES: 'Journey' pronounced with a hard J-O sound; 'gently' said as 'gentle'.</a:t>
-            </a:r>
-          </a:p>
-          <a:p/>
-          <a:p>
-            <a:r>
-              <a:t>IF THE STUDENT STRUGGLES (easier step): Say the word slowly in syllables and let them copy one syllable at a time.</a:t>
-            </a:r>
-          </a:p>
-          <a:p/>
-          <a:p>
-            <a:r>
-              <a:t>IF THE STUDENT FINISHES FAST (bonus): Ask: 'Which word could describe YOU today?'</a:t>
-            </a:r>
-          </a:p>
-          <a:p/>
-          <a:p>
-            <a:r>
-              <a:t>ENCOURAGE: Excellent! You said the hardest word on the page. ⭐</a:t>
-            </a:r>
-          </a:p>
         </p:txBody>
       </p:sp>
       <p:sp>
@@ -4232,53 +2714,7 @@
         <p:txBody>
           <a:bodyPr/>
           <a:lstStyle/>
-          <a:p>
-            <a:r>
-              <a:t>⏱ TIMING: 5–10 min</a:t>
-            </a:r>
-          </a:p>
           <a:p/>
-          <a:p>
-            <a:r>
-              <a:t>SAY: Detective time! I'll show you a picture clue and a hint. You guess the word. You get a star for every word you catch.</a:t>
-            </a:r>
-          </a:p>
-          <a:p/>
-          <a:p>
-            <a:r>
-              <a:t>HOW TO RUN IT: Reveal one card at a time by pointing. Give 5–8 seconds of thinking time before helping. Answers: hatchling, exhausted, volunteer, journey.</a:t>
-            </a:r>
-          </a:p>
-          <a:p/>
-          <a:p>
-            <a:r>
-              <a:t>EXPECTED ANSWERS: hatchling  •  exhausted  •  volunteer  •  journey</a:t>
-            </a:r>
-          </a:p>
-          <a:p/>
-          <a:p>
-            <a:r>
-              <a:t>COMMON MISTAKES: Saying 'hatched' instead of 'hatchling'; saying 'tired' instead of 'exhausted'.</a:t>
-            </a:r>
-          </a:p>
-          <a:p/>
-          <a:p>
-            <a:r>
-              <a:t>IF THE STUDENT STRUGGLES (easier step): Give the first sound: 'It starts with /h/...' then the first two letters.</a:t>
-            </a:r>
-          </a:p>
-          <a:p/>
-          <a:p>
-            <a:r>
-              <a:t>IF THE STUDENT FINISHES FAST (bonus): Ask them to make a sentence with the word they just guessed.</a:t>
-            </a:r>
-          </a:p>
-          <a:p/>
-          <a:p>
-            <a:r>
-              <a:t>ENCOURAGE: You got it! Real detective thinking. +1 Star ⭐</a:t>
-            </a:r>
-          </a:p>
         </p:txBody>
       </p:sp>
       <p:sp>
@@ -4344,53 +2780,7 @@
         <p:txBody>
           <a:bodyPr/>
           <a:lstStyle/>
-          <a:p>
-            <a:r>
-              <a:t>⏱ TIMING: 5–10 min</a:t>
-            </a:r>
-          </a:p>
           <a:p/>
-          <a:p>
-            <a:r>
-              <a:t>SAY: The imposters are here! Each row has one real word and two sneaky look-alikes. Read all three before you choose.</a:t>
-            </a:r>
-          </a:p>
-          <a:p/>
-          <a:p>
-            <a:r>
-              <a:t>HOW TO RUN IT: Read the question aloud, then read the three options slowly. Let the student point or say the answer. Answers: exhausted, journey, canyon.</a:t>
-            </a:r>
-          </a:p>
-          <a:p/>
-          <a:p>
-            <a:r>
-              <a:t>EXPECTED ANSWERS: exhausted  •  journey  •  canyon</a:t>
-            </a:r>
-          </a:p>
-          <a:p/>
-          <a:p>
-            <a:r>
-              <a:t>COMMON MISTAKES: Choosing by first letter only — picking 'excited' or 'cannon'.</a:t>
-            </a:r>
-          </a:p>
-          <a:p/>
-          <a:p>
-            <a:r>
-              <a:t>IF THE STUDENT STRUGGLES (easier step): Cover one wrong option with your hand to make it a 50/50 choice.</a:t>
-            </a:r>
-          </a:p>
-          <a:p/>
-          <a:p>
-            <a:r>
-              <a:t>IF THE STUDENT FINISHES FAST (bonus): Ask what the two imposter words actually mean.</a:t>
-            </a:r>
-          </a:p>
-          <a:p/>
-          <a:p>
-            <a:r>
-              <a:t>ENCOURAGE: Sharp eyes! You didn't fall for the trick. ⭐</a:t>
-            </a:r>
-          </a:p>
         </p:txBody>
       </p:sp>
       <p:sp>
@@ -4456,53 +2846,7 @@
         <p:txBody>
           <a:bodyPr/>
           <a:lstStyle/>
-          <a:p>
-            <a:r>
-              <a:t>⏱ TIMING: 10–20 min</a:t>
-            </a:r>
-          </a:p>
           <a:p/>
-          <a:p>
-            <a:r>
-              <a:t>SAY: Before we read a single word, good readers make predictions. Look at the title and the pictures. What do you think is going to happen?</a:t>
-            </a:r>
-          </a:p>
-          <a:p/>
-          <a:p>
-            <a:r>
-              <a:t>HOW TO RUN IT: Ask two or three of the questions, not all four. Accept every guess warmly and write one prediction down so you can check it after Part 3.</a:t>
-            </a:r>
-          </a:p>
-          <a:p/>
-          <a:p>
-            <a:r>
-              <a:t>EXPECTED ANSWERS: Any reasonable guess: Maya is a girl / a helper; turtles are lost; midnight because it is safer or cooler.</a:t>
-            </a:r>
-          </a:p>
-          <a:p/>
-          <a:p>
-            <a:r>
-              <a:t>COMMON MISTAKES: Saying 'I don't know' because they are afraid of being wrong.</a:t>
-            </a:r>
-          </a:p>
-          <a:p/>
-          <a:p>
-            <a:r>
-              <a:t>IF THE STUDENT STRUGGLES (easier step): Offer two options: 'Do you think Maya is a kid or a scientist?'</a:t>
-            </a:r>
-          </a:p>
-          <a:p/>
-          <a:p>
-            <a:r>
-              <a:t>IF THE STUDENT FINISHES FAST (bonus): Ask them to predict the LAST sentence of the story.</a:t>
-            </a:r>
-          </a:p>
-          <a:p/>
-          <a:p>
-            <a:r>
-              <a:t>ENCOURAGE: That is exactly what real readers do — great thinking! ⭐</a:t>
-            </a:r>
-          </a:p>
         </p:txBody>
       </p:sp>
       <p:sp>
@@ -4568,53 +2912,7 @@
         <p:txBody>
           <a:bodyPr/>
           <a:lstStyle/>
-          <a:p>
-            <a:r>
-              <a:t>⏱ TIMING: 10–20 min</a:t>
-            </a:r>
-          </a:p>
           <a:p/>
-          <a:p>
-            <a:r>
-              <a:t>SAY: I will read Part 1 out loud first. Your job is easy — follow along with your finger and listen to how I pause at the periods.</a:t>
-            </a:r>
-          </a:p>
-          <a:p/>
-          <a:p>
-            <a:r>
-              <a:t>HOW TO RUN IT: Read with expression at a slightly slow pace. Then ask one quick check question so the student stays active. Do not ask them to read yet.</a:t>
-            </a:r>
-          </a:p>
-          <a:p/>
-          <a:p>
-            <a:r>
-              <a:t>EXPECTED ANSWERS: Check question: 'Why do the volunteers use a RED flashlight?' → Because white light confuses the baby turtles.</a:t>
-            </a:r>
-          </a:p>
-          <a:p/>
-          <a:p>
-            <a:r>
-              <a:t>COMMON MISTAKES: Losing their place in the text; missing the red-light detail.</a:t>
-            </a:r>
-          </a:p>
-          <a:p/>
-          <a:p>
-            <a:r>
-              <a:t>IF THE STUDENT STRUGGLES (easier step): Re-read just the sentence about the red flashlight, then ask again.</a:t>
-            </a:r>
-          </a:p>
-          <a:p/>
-          <a:p>
-            <a:r>
-              <a:t>IF THE STUDENT FINISHES FAST (bonus): Ask: 'What time of year does this happen?' (August)</a:t>
-            </a:r>
-          </a:p>
-          <a:p/>
-          <a:p>
-            <a:r>
-              <a:t>ENCOURAGE: You followed every line — nice focus! ⭐</a:t>
-            </a:r>
-          </a:p>
         </p:txBody>
       </p:sp>
       <p:sp>

</xml_diff>